<commit_message>
docs: finalize deployment documentation team contributions and release notes
</commit_message>
<xml_diff>
--- a/docs/Presentation.pptx
+++ b/docs/Presentation.pptx
@@ -20,6 +20,7 @@
     <p:sldId id="268" r:id="rId20"/>
     <p:sldId id="269" r:id="rId21"/>
     <p:sldId id="270" r:id="rId22"/>
+    <p:sldId id="271" r:id="rId23"/>
   </p:sldIdLst>
   <p:sldSz cx="12191695" cy="6858000" type="screen4x3"/>
   <p:notesSz cx="6858000" cy="9144000"/>
@@ -516,7 +517,77 @@
           <a:lstStyle/>
           <a:p>
             <a:r>
-              <a:t>30-second hook — one searchable library for movies and books, live on MongoDB Atlas.</a:t>
+              <a:t>30-second hook — one searchable library for movies and books, live in production on Render + MongoDB Atlas.</a:t>
+            </a:r>
+          </a:p>
+        </p:txBody>
+      </p:sp>
+      <p:sp>
+        <p:nvSpPr>
+          <p:cNvPr id="4" name="Slide Number Placeholder 3"/>
+          <p:cNvSpPr>
+            <a:spLocks noGrp="1"/>
+          </p:cNvSpPr>
+          <p:nvPr>
+            <p:ph type="sldNum" idx="5" sz="quarter"/>
+          </p:nvPr>
+        </p:nvSpPr>
+        <p:spPr/>
+      </p:sp>
+    </p:spTree>
+  </p:cSld>
+  <p:clrMapOvr>
+    <a:masterClrMapping/>
+  </p:clrMapOvr>
+</p:notes>
+</file>
+
+<file path=ppt/notesSlides/notesSlide10.xml><?xml version="1.0" encoding="utf-8"?>
+<p:notes xmlns:a="http://schemas.openxmlformats.org/drawingml/2006/main" xmlns:p="http://schemas.openxmlformats.org/presentationml/2006/main" xmlns:r="http://schemas.openxmlformats.org/officeDocument/2006/relationships">
+  <p:cSld>
+    <p:spTree>
+      <p:nvGrpSpPr>
+        <p:cNvPr id="1" name=""/>
+        <p:cNvGrpSpPr/>
+        <p:nvPr/>
+      </p:nvGrpSpPr>
+      <p:grpSpPr>
+        <a:xfrm>
+          <a:off x="0" y="0"/>
+          <a:ext cx="0" cy="0"/>
+          <a:chOff x="0" y="0"/>
+          <a:chExt cx="0" cy="0"/>
+        </a:xfrm>
+      </p:grpSpPr>
+      <p:sp>
+        <p:nvSpPr>
+          <p:cNvPr id="2" name="Slide Image Placeholder 1"/>
+          <p:cNvSpPr>
+            <a:spLocks noGrp="1"/>
+          </p:cNvSpPr>
+          <p:nvPr>
+            <p:ph type="sldImg" idx="2"/>
+          </p:nvPr>
+        </p:nvSpPr>
+        <p:spPr/>
+      </p:sp>
+      <p:sp>
+        <p:nvSpPr>
+          <p:cNvPr id="3" name="Notes Placeholder 2"/>
+          <p:cNvSpPr>
+            <a:spLocks noGrp="1"/>
+          </p:cNvSpPr>
+          <p:nvPr>
+            <p:ph type="body" idx="3" sz="quarter"/>
+          </p:nvPr>
+        </p:nvSpPr>
+        <p:spPr/>
+        <p:txBody>
+          <a:bodyPr/>
+          <a:lstStyle/>
+          <a:p>
+            <a:r>
+              <a:t>Open both URLs live from this slide; expect a cold-start delay on the free tier.</a:t>
             </a:r>
           </a:p>
         </p:txBody>
@@ -936,7 +1007,7 @@
           <a:lstStyle/>
           <a:p>
             <a:r>
-              <a:t>Do the live demo from this slide.</a:t>
+              <a:t>Do the live demo from this slide (see Slide 16 for URLs).</a:t>
             </a:r>
           </a:p>
         </p:txBody>
@@ -4180,7 +4251,22 @@
               </a:defRPr>
             </a:pPr>
             <a:r>
-              <a:t>Team: Arun Jain (Backend, MongoDB, APIs, Integration) · Ansh (Frontend, UI) · Jheel (Docs, Report, PPT)</a:t>
+              <a:t>Live: https://movie-book-library-1.onrender.com (API: https://movie-book-library-ii96.onrender.com)</a:t>
+            </a:r>
+          </a:p>
+          <a:p>
+            <a:pPr>
+              <a:spcAft>
+                <a:spcPts val="800"/>
+              </a:spcAft>
+              <a:defRPr sz="1900">
+                <a:solidFill>
+                  <a:srgbClr val="333333"/>
+                </a:solidFill>
+              </a:defRPr>
+            </a:pPr>
+            <a:r>
+              <a:t>Team: Arun Kumar Jain (Backend Developer &amp; Integration Engineer) · Ansh (Frontend Developer) · Jheel (Documentation &amp; Project Delivery)</a:t>
             </a:r>
           </a:p>
         </p:txBody>
@@ -4422,7 +4508,7 @@
               </a:defRPr>
             </a:pPr>
             <a:r>
-              <a:t>Live demo order: search → filter → add → edit → delete</a:t>
+              <a:t>Live demo at https://movie-book-library-1.onrender.com — order: search → filter → add → edit → delete</a:t>
             </a:r>
           </a:p>
         </p:txBody>
@@ -5017,7 +5103,7 @@
               </a:defRPr>
             </a:pPr>
             <a:r>
-              <a:t>Team: Arun (backend/integration) · Ansh (frontend/UI) · Jheel (docs/packaging)</a:t>
+              <a:t>Released live: frontend https://movie-book-library-1.onrender.com, backend https://movie-book-library-ii96.onrender.com</a:t>
             </a:r>
           </a:p>
           <a:p>
@@ -5032,7 +5118,173 @@
               </a:defRPr>
             </a:pPr>
             <a:r>
+              <a:t>Team: Arun Kumar Jain (backend/integration/release) · Ansh (frontend/UI) · Jheel (docs/packaging)</a:t>
+            </a:r>
+          </a:p>
+          <a:p>
+            <a:pPr>
+              <a:spcAft>
+                <a:spcPts val="800"/>
+              </a:spcAft>
+              <a:defRPr sz="1900">
+                <a:solidFill>
+                  <a:srgbClr val="333333"/>
+                </a:solidFill>
+              </a:defRPr>
+            </a:pPr>
+            <a:r>
               <a:t>Thank you — open for questions</a:t>
+            </a:r>
+          </a:p>
+        </p:txBody>
+      </p:sp>
+    </p:spTree>
+  </p:cSld>
+  <p:clrMapOvr>
+    <a:masterClrMapping/>
+  </p:clrMapOvr>
+</p:sld>
+</file>
+
+<file path=ppt/slides/slide16.xml><?xml version="1.0" encoding="utf-8"?>
+<p:sld xmlns:a="http://schemas.openxmlformats.org/drawingml/2006/main" xmlns:p="http://schemas.openxmlformats.org/presentationml/2006/main" xmlns:r="http://schemas.openxmlformats.org/officeDocument/2006/relationships">
+  <p:cSld>
+    <p:spTree>
+      <p:nvGrpSpPr>
+        <p:cNvPr id="1" name=""/>
+        <p:cNvGrpSpPr/>
+        <p:nvPr/>
+      </p:nvGrpSpPr>
+      <p:grpSpPr/>
+      <p:sp>
+        <p:nvSpPr>
+          <p:cNvPr id="2" name="TextBox 1"/>
+          <p:cNvSpPr txBox="1"/>
+          <p:nvPr/>
+        </p:nvSpPr>
+        <p:spPr>
+          <a:xfrm>
+            <a:off x="457200" y="137160"/>
+            <a:ext cx="11247120" cy="822960"/>
+          </a:xfrm>
+          <a:prstGeom prst="rect">
+            <a:avLst/>
+          </a:prstGeom>
+          <a:noFill/>
+        </p:spPr>
+        <p:txBody>
+          <a:bodyPr wrap="none">
+            <a:spAutoFit/>
+          </a:bodyPr>
+          <a:lstStyle/>
+          <a:p>
+            <a:pPr>
+              <a:defRPr sz="3400" b="1">
+                <a:solidFill>
+                  <a:srgbClr val="1E3A5F"/>
+                </a:solidFill>
+              </a:defRPr>
+            </a:pPr>
+            <a:r>
+              <a:t>Live Deployment &amp; Release</a:t>
+            </a:r>
+          </a:p>
+        </p:txBody>
+      </p:sp>
+      <p:sp>
+        <p:nvSpPr>
+          <p:cNvPr id="3" name="TextBox 2"/>
+          <p:cNvSpPr txBox="1"/>
+          <p:nvPr/>
+        </p:nvSpPr>
+        <p:spPr>
+          <a:xfrm>
+            <a:off x="457200" y="1143000"/>
+            <a:ext cx="11247120" cy="5029200"/>
+          </a:xfrm>
+          <a:prstGeom prst="rect">
+            <a:avLst/>
+          </a:prstGeom>
+          <a:noFill/>
+        </p:spPr>
+        <p:txBody>
+          <a:bodyPr wrap="square">
+            <a:spAutoFit/>
+          </a:bodyPr>
+          <a:lstStyle/>
+          <a:p>
+            <a:pPr>
+              <a:spcAft>
+                <a:spcPts val="800"/>
+              </a:spcAft>
+              <a:defRPr sz="1900">
+                <a:solidFill>
+                  <a:srgbClr val="333333"/>
+                </a:solidFill>
+              </a:defRPr>
+            </a:pPr>
+            <a:r>
+              <a:t>Frontend: Render Static Site — https://movie-book-library-1.onrender.com</a:t>
+            </a:r>
+          </a:p>
+          <a:p>
+            <a:pPr>
+              <a:spcAft>
+                <a:spcPts val="800"/>
+              </a:spcAft>
+              <a:defRPr sz="1900">
+                <a:solidFill>
+                  <a:srgbClr val="333333"/>
+                </a:solidFill>
+              </a:defRPr>
+            </a:pPr>
+            <a:r>
+              <a:t>Backend: Render Web Service — https://movie-book-library-ii96.onrender.com (health endpoint verified live)</a:t>
+            </a:r>
+          </a:p>
+          <a:p>
+            <a:pPr>
+              <a:spcAft>
+                <a:spcPts val="800"/>
+              </a:spcAft>
+              <a:defRPr sz="1900">
+                <a:solidFill>
+                  <a:srgbClr val="333333"/>
+                </a:solidFill>
+              </a:defRPr>
+            </a:pPr>
+            <a:r>
+              <a:t>Database: MongoDB Atlas (`movie.items`); frontend built with production `VITE_API_URL`</a:t>
+            </a:r>
+          </a:p>
+          <a:p>
+            <a:pPr>
+              <a:spcAft>
+                <a:spcPts val="800"/>
+              </a:spcAft>
+              <a:defRPr sz="1900">
+                <a:solidFill>
+                  <a:srgbClr val="333333"/>
+                </a:solidFill>
+              </a:defRPr>
+            </a:pPr>
+            <a:r>
+              <a:t>Live demo order: search → filter → add → edit → delete, then confirm in Atlas</a:t>
+            </a:r>
+          </a:p>
+          <a:p>
+            <a:pPr>
+              <a:spcAft>
+                <a:spcPts val="800"/>
+              </a:spcAft>
+              <a:defRPr sz="1900">
+                <a:solidFill>
+                  <a:srgbClr val="333333"/>
+                </a:solidFill>
+              </a:defRPr>
+            </a:pPr>
+            <a:r>
+              <a:t>No CRUD, UI or schema changes were needed for release</a:t>
             </a:r>
           </a:p>
         </p:txBody>
@@ -5722,6 +5974,21 @@
             </a:pPr>
             <a:r>
               <a:t>Flow: filter change → query string → Mongo filter/sort/skip/limit → cards re-render</a:t>
+            </a:r>
+          </a:p>
+          <a:p>
+            <a:pPr>
+              <a:spcAft>
+                <a:spcPts val="800"/>
+              </a:spcAft>
+              <a:defRPr sz="1900">
+                <a:solidFill>
+                  <a:srgbClr val="333333"/>
+                </a:solidFill>
+              </a:defRPr>
+            </a:pPr>
+            <a:r>
+              <a:t>Hosting: frontend = Render Static Site, backend = Render Web Service, database = MongoDB Atlas</a:t>
             </a:r>
           </a:p>
         </p:txBody>

</xml_diff>